<commit_message>
Drop Sale / Leads and raw field names from the acquisition slides
Co-Authored-By: Claude Opus 5.5 <noreply@anthropic.com>
Claude-Session: https://claude.ai/code/session_014MFVAhSTQkwMpsqmffjDH4
</commit_message>
<xml_diff>
--- a/deck/output/Farmer Acquisition 5-11 Oct 2026.pptx
+++ b/deck/output/Farmer Acquisition 5-11 Oct 2026.pptx
@@ -2812,7 +2812,7 @@
                 <a:ea typeface="Plus Jakarta Sans" pitchFamily="34" charset="-122"/>
                 <a:cs typeface="Plus Jakarta Sans" pitchFamily="34" charset="-120"/>
               </a:rPr>
-              <a:t>Farmers counted by registration week (minggu_register). The week of 12 Oct is in progress and left out. Duta = akuisisi_type “Under Duta”, internal-team and external Dutas alike.</a:t>
+              <a:t>Farmers counted by the week they registered. The week of 12 Oct is in progress and left out. Duta covers internal-team and external Dutas alike.</a:t>
             </a:r>
             <a:endParaRPr lang="en-US" sz="950" dirty="0"/>
           </a:p>
@@ -5762,12 +5762,11 @@
             <a:tbl>
               <a:tblPr/>
               <a:tblGrid>
-                <a:gridCol w="1279585"/>
-                <a:gridCol w="938362"/>
-                <a:gridCol w="554487"/>
-                <a:gridCol w="554487"/>
-                <a:gridCol w="511834"/>
-                <a:gridCol w="682445"/>
+                <a:gridCol w="1446784"/>
+                <a:gridCol w="1085088"/>
+                <a:gridCol w="678180"/>
+                <a:gridCol w="678180"/>
+                <a:gridCol w="632968"/>
               </a:tblGrid>
               <a:tr h="0">
                 <a:tc>
@@ -6060,74 +6059,6 @@
                           <a:cs typeface="Plus Jakarta Sans" pitchFamily="34" charset="-120"/>
                         </a:rPr>
                         <a:t>7 weeks</a:t>
-                      </a:r>
-                      <a:endParaRPr lang="en-US" sz="900" dirty="0">
-                        <a:latin typeface="Plus Jakarta Sans" charset="0"/>
-                        <a:ea typeface="Plus Jakarta Sans" charset="0"/>
-                        <a:cs typeface="Plus Jakarta Sans" charset="0"/>
-                      </a:endParaRPr>
-                    </a:p>
-                  </a:txBody>
-                  <a:tcPr marL="36576" marR="36576" marT="36576" marB="36576" anchor="ctr">
-                    <a:lnL w="6350" cap="flat" cmpd="sng" algn="ctr">
-                      <a:solidFill>
-                        <a:srgbClr val="DCE2D6"/>
-                      </a:solidFill>
-                      <a:prstDash val="solid"/>
-                      <a:round/>
-                      <a:headEnd type="none" w="med" len="med"/>
-                      <a:tailEnd type="none" w="med" len="med"/>
-                    </a:lnL>
-                    <a:lnR w="6350" cap="flat" cmpd="sng" algn="ctr">
-                      <a:solidFill>
-                        <a:srgbClr val="DCE2D6"/>
-                      </a:solidFill>
-                      <a:prstDash val="solid"/>
-                      <a:round/>
-                      <a:headEnd type="none" w="med" len="med"/>
-                      <a:tailEnd type="none" w="med" len="med"/>
-                    </a:lnR>
-                    <a:lnT w="6350" cap="flat" cmpd="sng" algn="ctr">
-                      <a:solidFill>
-                        <a:srgbClr val="DCE2D6"/>
-                      </a:solidFill>
-                      <a:prstDash val="solid"/>
-                      <a:round/>
-                      <a:headEnd type="none" w="med" len="med"/>
-                      <a:tailEnd type="none" w="med" len="med"/>
-                    </a:lnT>
-                    <a:lnB w="6350" cap="flat" cmpd="sng" algn="ctr">
-                      <a:solidFill>
-                        <a:srgbClr val="DCE2D6"/>
-                      </a:solidFill>
-                      <a:prstDash val="solid"/>
-                      <a:round/>
-                      <a:headEnd type="none" w="med" len="med"/>
-                      <a:tailEnd type="none" w="med" len="med"/>
-                    </a:lnB>
-                    <a:solidFill>
-                      <a:srgbClr val="4A653B"/>
-                    </a:solidFill>
-                  </a:tcPr>
-                </a:tc>
-                <a:tc>
-                  <a:txBody>
-                    <a:bodyPr/>
-                    <a:lstStyle/>
-                    <a:p>
-                      <a:pPr algn="r" indent="0" marL="0">
-                        <a:buNone/>
-                      </a:pPr>
-                      <a:r>
-                        <a:rPr lang="en-US" sz="900" b="1" dirty="0">
-                          <a:solidFill>
-                            <a:srgbClr val="FFFFFF"/>
-                          </a:solidFill>
-                          <a:latin typeface="Plus Jakarta Sans" pitchFamily="34" charset="0"/>
-                          <a:ea typeface="Plus Jakarta Sans" pitchFamily="34" charset="-122"/>
-                          <a:cs typeface="Plus Jakarta Sans" pitchFamily="34" charset="-120"/>
-                        </a:rPr>
-                        <a:t>Sale / Leads</a:t>
                       </a:r>
                       <a:endParaRPr lang="en-US" sz="900" dirty="0">
                         <a:latin typeface="Plus Jakarta Sans" charset="0"/>
@@ -6505,71 +6436,6 @@
                     </a:lnB>
                   </a:tcPr>
                 </a:tc>
-                <a:tc>
-                  <a:txBody>
-                    <a:bodyPr/>
-                    <a:lstStyle/>
-                    <a:p>
-                      <a:pPr algn="r" indent="0" marL="0">
-                        <a:buNone/>
-                      </a:pPr>
-                      <a:r>
-                        <a:rPr lang="en-US" sz="900" dirty="0">
-                          <a:solidFill>
-                            <a:srgbClr val="2B2F28"/>
-                          </a:solidFill>
-                          <a:latin typeface="Plus Jakarta Sans" pitchFamily="34" charset="0"/>
-                          <a:ea typeface="Plus Jakarta Sans" pitchFamily="34" charset="-122"/>
-                          <a:cs typeface="Plus Jakarta Sans" pitchFamily="34" charset="-120"/>
-                        </a:rPr>
-                        <a:t>5 / 4</a:t>
-                      </a:r>
-                      <a:endParaRPr lang="en-US" sz="900" dirty="0">
-                        <a:latin typeface="Plus Jakarta Sans" charset="0"/>
-                        <a:ea typeface="Plus Jakarta Sans" charset="0"/>
-                        <a:cs typeface="Plus Jakarta Sans" charset="0"/>
-                      </a:endParaRPr>
-                    </a:p>
-                  </a:txBody>
-                  <a:tcPr marL="36576" marR="36576" marT="36576" marB="36576" anchor="ctr">
-                    <a:lnL w="6350" cap="flat" cmpd="sng" algn="ctr">
-                      <a:solidFill>
-                        <a:srgbClr val="DCE2D6"/>
-                      </a:solidFill>
-                      <a:prstDash val="solid"/>
-                      <a:round/>
-                      <a:headEnd type="none" w="med" len="med"/>
-                      <a:tailEnd type="none" w="med" len="med"/>
-                    </a:lnL>
-                    <a:lnR w="6350" cap="flat" cmpd="sng" algn="ctr">
-                      <a:solidFill>
-                        <a:srgbClr val="DCE2D6"/>
-                      </a:solidFill>
-                      <a:prstDash val="solid"/>
-                      <a:round/>
-                      <a:headEnd type="none" w="med" len="med"/>
-                      <a:tailEnd type="none" w="med" len="med"/>
-                    </a:lnR>
-                    <a:lnT w="6350" cap="flat" cmpd="sng" algn="ctr">
-                      <a:solidFill>
-                        <a:srgbClr val="DCE2D6"/>
-                      </a:solidFill>
-                      <a:prstDash val="solid"/>
-                      <a:round/>
-                      <a:headEnd type="none" w="med" len="med"/>
-                      <a:tailEnd type="none" w="med" len="med"/>
-                    </a:lnT>
-                    <a:lnB w="6350" cap="flat" cmpd="sng" algn="ctr">
-                      <a:solidFill>
-                        <a:srgbClr val="DCE2D6"/>
-                      </a:solidFill>
-                      <a:prstDash val="solid"/>
-                      <a:round/>
-                      <a:headEnd type="none" w="med" len="med"/>
-                      <a:tailEnd type="none" w="med" len="med"/>
-                    </a:lnB>
-                  </a:tcPr>
-                </a:tc>
               </a:tr>
               <a:tr h="0">
                 <a:tc>
@@ -6850,71 +6716,6 @@
                           <a:cs typeface="Plus Jakarta Sans" pitchFamily="34" charset="-120"/>
                         </a:rPr>
                         <a:t>1</a:t>
-                      </a:r>
-                      <a:endParaRPr lang="en-US" sz="900" dirty="0">
-                        <a:latin typeface="Plus Jakarta Sans" charset="0"/>
-                        <a:ea typeface="Plus Jakarta Sans" charset="0"/>
-                        <a:cs typeface="Plus Jakarta Sans" charset="0"/>
-                      </a:endParaRPr>
-                    </a:p>
-                  </a:txBody>
-                  <a:tcPr marL="36576" marR="36576" marT="36576" marB="36576" anchor="ctr">
-                    <a:lnL w="6350" cap="flat" cmpd="sng" algn="ctr">
-                      <a:solidFill>
-                        <a:srgbClr val="DCE2D6"/>
-                      </a:solidFill>
-                      <a:prstDash val="solid"/>
-                      <a:round/>
-                      <a:headEnd type="none" w="med" len="med"/>
-                      <a:tailEnd type="none" w="med" len="med"/>
-                    </a:lnL>
-                    <a:lnR w="6350" cap="flat" cmpd="sng" algn="ctr">
-                      <a:solidFill>
-                        <a:srgbClr val="DCE2D6"/>
-                      </a:solidFill>
-                      <a:prstDash val="solid"/>
-                      <a:round/>
-                      <a:headEnd type="none" w="med" len="med"/>
-                      <a:tailEnd type="none" w="med" len="med"/>
-                    </a:lnR>
-                    <a:lnT w="6350" cap="flat" cmpd="sng" algn="ctr">
-                      <a:solidFill>
-                        <a:srgbClr val="DCE2D6"/>
-                      </a:solidFill>
-                      <a:prstDash val="solid"/>
-                      <a:round/>
-                      <a:headEnd type="none" w="med" len="med"/>
-                      <a:tailEnd type="none" w="med" len="med"/>
-                    </a:lnT>
-                    <a:lnB w="6350" cap="flat" cmpd="sng" algn="ctr">
-                      <a:solidFill>
-                        <a:srgbClr val="DCE2D6"/>
-                      </a:solidFill>
-                      <a:prstDash val="solid"/>
-                      <a:round/>
-                      <a:headEnd type="none" w="med" len="med"/>
-                      <a:tailEnd type="none" w="med" len="med"/>
-                    </a:lnB>
-                  </a:tcPr>
-                </a:tc>
-                <a:tc>
-                  <a:txBody>
-                    <a:bodyPr/>
-                    <a:lstStyle/>
-                    <a:p>
-                      <a:pPr algn="r" indent="0" marL="0">
-                        <a:buNone/>
-                      </a:pPr>
-                      <a:r>
-                        <a:rPr lang="en-US" sz="900" dirty="0">
-                          <a:solidFill>
-                            <a:srgbClr val="2B2F28"/>
-                          </a:solidFill>
-                          <a:latin typeface="Plus Jakarta Sans" pitchFamily="34" charset="0"/>
-                          <a:ea typeface="Plus Jakarta Sans" pitchFamily="34" charset="-122"/>
-                          <a:cs typeface="Plus Jakarta Sans" pitchFamily="34" charset="-120"/>
-                        </a:rPr>
-                        <a:t>1 / 0</a:t>
                       </a:r>
                       <a:endParaRPr lang="en-US" sz="900" dirty="0">
                         <a:latin typeface="Plus Jakarta Sans" charset="0"/>
@@ -7289,71 +7090,6 @@
                     </a:lnB>
                   </a:tcPr>
                 </a:tc>
-                <a:tc>
-                  <a:txBody>
-                    <a:bodyPr/>
-                    <a:lstStyle/>
-                    <a:p>
-                      <a:pPr algn="r" indent="0" marL="0">
-                        <a:buNone/>
-                      </a:pPr>
-                      <a:r>
-                        <a:rPr lang="en-US" sz="900" dirty="0">
-                          <a:solidFill>
-                            <a:srgbClr val="2B2F28"/>
-                          </a:solidFill>
-                          <a:latin typeface="Plus Jakarta Sans" pitchFamily="34" charset="0"/>
-                          <a:ea typeface="Plus Jakarta Sans" pitchFamily="34" charset="-122"/>
-                          <a:cs typeface="Plus Jakarta Sans" pitchFamily="34" charset="-120"/>
-                        </a:rPr>
-                        <a:t>0 / 1</a:t>
-                      </a:r>
-                      <a:endParaRPr lang="en-US" sz="900" dirty="0">
-                        <a:latin typeface="Plus Jakarta Sans" charset="0"/>
-                        <a:ea typeface="Plus Jakarta Sans" charset="0"/>
-                        <a:cs typeface="Plus Jakarta Sans" charset="0"/>
-                      </a:endParaRPr>
-                    </a:p>
-                  </a:txBody>
-                  <a:tcPr marL="36576" marR="36576" marT="36576" marB="36576" anchor="ctr">
-                    <a:lnL w="6350" cap="flat" cmpd="sng" algn="ctr">
-                      <a:solidFill>
-                        <a:srgbClr val="DCE2D6"/>
-                      </a:solidFill>
-                      <a:prstDash val="solid"/>
-                      <a:round/>
-                      <a:headEnd type="none" w="med" len="med"/>
-                      <a:tailEnd type="none" w="med" len="med"/>
-                    </a:lnL>
-                    <a:lnR w="6350" cap="flat" cmpd="sng" algn="ctr">
-                      <a:solidFill>
-                        <a:srgbClr val="DCE2D6"/>
-                      </a:solidFill>
-                      <a:prstDash val="solid"/>
-                      <a:round/>
-                      <a:headEnd type="none" w="med" len="med"/>
-                      <a:tailEnd type="none" w="med" len="med"/>
-                    </a:lnR>
-                    <a:lnT w="6350" cap="flat" cmpd="sng" algn="ctr">
-                      <a:solidFill>
-                        <a:srgbClr val="DCE2D6"/>
-                      </a:solidFill>
-                      <a:prstDash val="solid"/>
-                      <a:round/>
-                      <a:headEnd type="none" w="med" len="med"/>
-                      <a:tailEnd type="none" w="med" len="med"/>
-                    </a:lnT>
-                    <a:lnB w="6350" cap="flat" cmpd="sng" algn="ctr">
-                      <a:solidFill>
-                        <a:srgbClr val="DCE2D6"/>
-                      </a:solidFill>
-                      <a:prstDash val="solid"/>
-                      <a:round/>
-                      <a:headEnd type="none" w="med" len="med"/>
-                      <a:tailEnd type="none" w="med" len="med"/>
-                    </a:lnB>
-                  </a:tcPr>
-                </a:tc>
               </a:tr>
               <a:tr h="0">
                 <a:tc>
@@ -7634,71 +7370,6 @@
                           <a:cs typeface="Plus Jakarta Sans" pitchFamily="34" charset="-120"/>
                         </a:rPr>
                         <a:t>3</a:t>
-                      </a:r>
-                      <a:endParaRPr lang="en-US" sz="900" dirty="0">
-                        <a:latin typeface="Plus Jakarta Sans" charset="0"/>
-                        <a:ea typeface="Plus Jakarta Sans" charset="0"/>
-                        <a:cs typeface="Plus Jakarta Sans" charset="0"/>
-                      </a:endParaRPr>
-                    </a:p>
-                  </a:txBody>
-                  <a:tcPr marL="36576" marR="36576" marT="36576" marB="36576" anchor="ctr">
-                    <a:lnL w="6350" cap="flat" cmpd="sng" algn="ctr">
-                      <a:solidFill>
-                        <a:srgbClr val="DCE2D6"/>
-                      </a:solidFill>
-                      <a:prstDash val="solid"/>
-                      <a:round/>
-                      <a:headEnd type="none" w="med" len="med"/>
-                      <a:tailEnd type="none" w="med" len="med"/>
-                    </a:lnL>
-                    <a:lnR w="6350" cap="flat" cmpd="sng" algn="ctr">
-                      <a:solidFill>
-                        <a:srgbClr val="DCE2D6"/>
-                      </a:solidFill>
-                      <a:prstDash val="solid"/>
-                      <a:round/>
-                      <a:headEnd type="none" w="med" len="med"/>
-                      <a:tailEnd type="none" w="med" len="med"/>
-                    </a:lnR>
-                    <a:lnT w="6350" cap="flat" cmpd="sng" algn="ctr">
-                      <a:solidFill>
-                        <a:srgbClr val="DCE2D6"/>
-                      </a:solidFill>
-                      <a:prstDash val="solid"/>
-                      <a:round/>
-                      <a:headEnd type="none" w="med" len="med"/>
-                      <a:tailEnd type="none" w="med" len="med"/>
-                    </a:lnT>
-                    <a:lnB w="6350" cap="flat" cmpd="sng" algn="ctr">
-                      <a:solidFill>
-                        <a:srgbClr val="DCE2D6"/>
-                      </a:solidFill>
-                      <a:prstDash val="solid"/>
-                      <a:round/>
-                      <a:headEnd type="none" w="med" len="med"/>
-                      <a:tailEnd type="none" w="med" len="med"/>
-                    </a:lnB>
-                  </a:tcPr>
-                </a:tc>
-                <a:tc>
-                  <a:txBody>
-                    <a:bodyPr/>
-                    <a:lstStyle/>
-                    <a:p>
-                      <a:pPr algn="r" indent="0" marL="0">
-                        <a:buNone/>
-                      </a:pPr>
-                      <a:r>
-                        <a:rPr lang="en-US" sz="900" dirty="0">
-                          <a:solidFill>
-                            <a:srgbClr val="2B2F28"/>
-                          </a:solidFill>
-                          <a:latin typeface="Plus Jakarta Sans" pitchFamily="34" charset="0"/>
-                          <a:ea typeface="Plus Jakarta Sans" pitchFamily="34" charset="-122"/>
-                          <a:cs typeface="Plus Jakarta Sans" pitchFamily="34" charset="-120"/>
-                        </a:rPr>
-                        <a:t>3 / 0</a:t>
                       </a:r>
                       <a:endParaRPr lang="en-US" sz="900" dirty="0">
                         <a:latin typeface="Plus Jakarta Sans" charset="0"/>
@@ -8073,71 +7744,6 @@
                     </a:lnB>
                   </a:tcPr>
                 </a:tc>
-                <a:tc>
-                  <a:txBody>
-                    <a:bodyPr/>
-                    <a:lstStyle/>
-                    <a:p>
-                      <a:pPr algn="r" indent="0" marL="0">
-                        <a:buNone/>
-                      </a:pPr>
-                      <a:r>
-                        <a:rPr lang="en-US" sz="900" dirty="0">
-                          <a:solidFill>
-                            <a:srgbClr val="2B2F28"/>
-                          </a:solidFill>
-                          <a:latin typeface="Plus Jakarta Sans" pitchFamily="34" charset="0"/>
-                          <a:ea typeface="Plus Jakarta Sans" pitchFamily="34" charset="-122"/>
-                          <a:cs typeface="Plus Jakarta Sans" pitchFamily="34" charset="-120"/>
-                        </a:rPr>
-                        <a:t>2 / 1</a:t>
-                      </a:r>
-                      <a:endParaRPr lang="en-US" sz="900" dirty="0">
-                        <a:latin typeface="Plus Jakarta Sans" charset="0"/>
-                        <a:ea typeface="Plus Jakarta Sans" charset="0"/>
-                        <a:cs typeface="Plus Jakarta Sans" charset="0"/>
-                      </a:endParaRPr>
-                    </a:p>
-                  </a:txBody>
-                  <a:tcPr marL="36576" marR="36576" marT="36576" marB="36576" anchor="ctr">
-                    <a:lnL w="6350" cap="flat" cmpd="sng" algn="ctr">
-                      <a:solidFill>
-                        <a:srgbClr val="DCE2D6"/>
-                      </a:solidFill>
-                      <a:prstDash val="solid"/>
-                      <a:round/>
-                      <a:headEnd type="none" w="med" len="med"/>
-                      <a:tailEnd type="none" w="med" len="med"/>
-                    </a:lnL>
-                    <a:lnR w="6350" cap="flat" cmpd="sng" algn="ctr">
-                      <a:solidFill>
-                        <a:srgbClr val="DCE2D6"/>
-                      </a:solidFill>
-                      <a:prstDash val="solid"/>
-                      <a:round/>
-                      <a:headEnd type="none" w="med" len="med"/>
-                      <a:tailEnd type="none" w="med" len="med"/>
-                    </a:lnR>
-                    <a:lnT w="6350" cap="flat" cmpd="sng" algn="ctr">
-                      <a:solidFill>
-                        <a:srgbClr val="DCE2D6"/>
-                      </a:solidFill>
-                      <a:prstDash val="solid"/>
-                      <a:round/>
-                      <a:headEnd type="none" w="med" len="med"/>
-                      <a:tailEnd type="none" w="med" len="med"/>
-                    </a:lnT>
-                    <a:lnB w="6350" cap="flat" cmpd="sng" algn="ctr">
-                      <a:solidFill>
-                        <a:srgbClr val="DCE2D6"/>
-                      </a:solidFill>
-                      <a:prstDash val="solid"/>
-                      <a:round/>
-                      <a:headEnd type="none" w="med" len="med"/>
-                      <a:tailEnd type="none" w="med" len="med"/>
-                    </a:lnB>
-                  </a:tcPr>
-                </a:tc>
               </a:tr>
               <a:tr h="0">
                 <a:tc>
@@ -8418,71 +8024,6 @@
                           <a:cs typeface="Plus Jakarta Sans" pitchFamily="34" charset="-120"/>
                         </a:rPr>
                         <a:t>2</a:t>
-                      </a:r>
-                      <a:endParaRPr lang="en-US" sz="900" dirty="0">
-                        <a:latin typeface="Plus Jakarta Sans" charset="0"/>
-                        <a:ea typeface="Plus Jakarta Sans" charset="0"/>
-                        <a:cs typeface="Plus Jakarta Sans" charset="0"/>
-                      </a:endParaRPr>
-                    </a:p>
-                  </a:txBody>
-                  <a:tcPr marL="36576" marR="36576" marT="36576" marB="36576" anchor="ctr">
-                    <a:lnL w="6350" cap="flat" cmpd="sng" algn="ctr">
-                      <a:solidFill>
-                        <a:srgbClr val="DCE2D6"/>
-                      </a:solidFill>
-                      <a:prstDash val="solid"/>
-                      <a:round/>
-                      <a:headEnd type="none" w="med" len="med"/>
-                      <a:tailEnd type="none" w="med" len="med"/>
-                    </a:lnL>
-                    <a:lnR w="6350" cap="flat" cmpd="sng" algn="ctr">
-                      <a:solidFill>
-                        <a:srgbClr val="DCE2D6"/>
-                      </a:solidFill>
-                      <a:prstDash val="solid"/>
-                      <a:round/>
-                      <a:headEnd type="none" w="med" len="med"/>
-                      <a:tailEnd type="none" w="med" len="med"/>
-                    </a:lnR>
-                    <a:lnT w="6350" cap="flat" cmpd="sng" algn="ctr">
-                      <a:solidFill>
-                        <a:srgbClr val="DCE2D6"/>
-                      </a:solidFill>
-                      <a:prstDash val="solid"/>
-                      <a:round/>
-                      <a:headEnd type="none" w="med" len="med"/>
-                      <a:tailEnd type="none" w="med" len="med"/>
-                    </a:lnT>
-                    <a:lnB w="6350" cap="flat" cmpd="sng" algn="ctr">
-                      <a:solidFill>
-                        <a:srgbClr val="DCE2D6"/>
-                      </a:solidFill>
-                      <a:prstDash val="solid"/>
-                      <a:round/>
-                      <a:headEnd type="none" w="med" len="med"/>
-                      <a:tailEnd type="none" w="med" len="med"/>
-                    </a:lnB>
-                  </a:tcPr>
-                </a:tc>
-                <a:tc>
-                  <a:txBody>
-                    <a:bodyPr/>
-                    <a:lstStyle/>
-                    <a:p>
-                      <a:pPr algn="r" indent="0" marL="0">
-                        <a:buNone/>
-                      </a:pPr>
-                      <a:r>
-                        <a:rPr lang="en-US" sz="900" dirty="0">
-                          <a:solidFill>
-                            <a:srgbClr val="2B2F28"/>
-                          </a:solidFill>
-                          <a:latin typeface="Plus Jakarta Sans" pitchFamily="34" charset="0"/>
-                          <a:ea typeface="Plus Jakarta Sans" pitchFamily="34" charset="-122"/>
-                          <a:cs typeface="Plus Jakarta Sans" pitchFamily="34" charset="-120"/>
-                        </a:rPr>
-                        <a:t>0 / 2</a:t>
                       </a:r>
                       <a:endParaRPr lang="en-US" sz="900" dirty="0">
                         <a:latin typeface="Plus Jakarta Sans" charset="0"/>
@@ -8857,71 +8398,6 @@
                     </a:lnB>
                   </a:tcPr>
                 </a:tc>
-                <a:tc>
-                  <a:txBody>
-                    <a:bodyPr/>
-                    <a:lstStyle/>
-                    <a:p>
-                      <a:pPr algn="r" indent="0" marL="0">
-                        <a:buNone/>
-                      </a:pPr>
-                      <a:r>
-                        <a:rPr lang="en-US" sz="900" dirty="0">
-                          <a:solidFill>
-                            <a:srgbClr val="2B2F28"/>
-                          </a:solidFill>
-                          <a:latin typeface="Plus Jakarta Sans" pitchFamily="34" charset="0"/>
-                          <a:ea typeface="Plus Jakarta Sans" pitchFamily="34" charset="-122"/>
-                          <a:cs typeface="Plus Jakarta Sans" pitchFamily="34" charset="-120"/>
-                        </a:rPr>
-                        <a:t>0 / 2</a:t>
-                      </a:r>
-                      <a:endParaRPr lang="en-US" sz="900" dirty="0">
-                        <a:latin typeface="Plus Jakarta Sans" charset="0"/>
-                        <a:ea typeface="Plus Jakarta Sans" charset="0"/>
-                        <a:cs typeface="Plus Jakarta Sans" charset="0"/>
-                      </a:endParaRPr>
-                    </a:p>
-                  </a:txBody>
-                  <a:tcPr marL="36576" marR="36576" marT="36576" marB="36576" anchor="ctr">
-                    <a:lnL w="6350" cap="flat" cmpd="sng" algn="ctr">
-                      <a:solidFill>
-                        <a:srgbClr val="DCE2D6"/>
-                      </a:solidFill>
-                      <a:prstDash val="solid"/>
-                      <a:round/>
-                      <a:headEnd type="none" w="med" len="med"/>
-                      <a:tailEnd type="none" w="med" len="med"/>
-                    </a:lnL>
-                    <a:lnR w="6350" cap="flat" cmpd="sng" algn="ctr">
-                      <a:solidFill>
-                        <a:srgbClr val="DCE2D6"/>
-                      </a:solidFill>
-                      <a:prstDash val="solid"/>
-                      <a:round/>
-                      <a:headEnd type="none" w="med" len="med"/>
-                      <a:tailEnd type="none" w="med" len="med"/>
-                    </a:lnR>
-                    <a:lnT w="6350" cap="flat" cmpd="sng" algn="ctr">
-                      <a:solidFill>
-                        <a:srgbClr val="DCE2D6"/>
-                      </a:solidFill>
-                      <a:prstDash val="solid"/>
-                      <a:round/>
-                      <a:headEnd type="none" w="med" len="med"/>
-                      <a:tailEnd type="none" w="med" len="med"/>
-                    </a:lnT>
-                    <a:lnB w="6350" cap="flat" cmpd="sng" algn="ctr">
-                      <a:solidFill>
-                        <a:srgbClr val="DCE2D6"/>
-                      </a:solidFill>
-                      <a:prstDash val="solid"/>
-                      <a:round/>
-                      <a:headEnd type="none" w="med" len="med"/>
-                      <a:tailEnd type="none" w="med" len="med"/>
-                    </a:lnB>
-                  </a:tcPr>
-                </a:tc>
               </a:tr>
               <a:tr h="0">
                 <a:tc>
@@ -9202,71 +8678,6 @@
                           <a:cs typeface="Plus Jakarta Sans" pitchFamily="34" charset="-120"/>
                         </a:rPr>
                         <a:t>1</a:t>
-                      </a:r>
-                      <a:endParaRPr lang="en-US" sz="900" dirty="0">
-                        <a:latin typeface="Plus Jakarta Sans" charset="0"/>
-                        <a:ea typeface="Plus Jakarta Sans" charset="0"/>
-                        <a:cs typeface="Plus Jakarta Sans" charset="0"/>
-                      </a:endParaRPr>
-                    </a:p>
-                  </a:txBody>
-                  <a:tcPr marL="36576" marR="36576" marT="36576" marB="36576" anchor="ctr">
-                    <a:lnL w="6350" cap="flat" cmpd="sng" algn="ctr">
-                      <a:solidFill>
-                        <a:srgbClr val="DCE2D6"/>
-                      </a:solidFill>
-                      <a:prstDash val="solid"/>
-                      <a:round/>
-                      <a:headEnd type="none" w="med" len="med"/>
-                      <a:tailEnd type="none" w="med" len="med"/>
-                    </a:lnL>
-                    <a:lnR w="6350" cap="flat" cmpd="sng" algn="ctr">
-                      <a:solidFill>
-                        <a:srgbClr val="DCE2D6"/>
-                      </a:solidFill>
-                      <a:prstDash val="solid"/>
-                      <a:round/>
-                      <a:headEnd type="none" w="med" len="med"/>
-                      <a:tailEnd type="none" w="med" len="med"/>
-                    </a:lnR>
-                    <a:lnT w="6350" cap="flat" cmpd="sng" algn="ctr">
-                      <a:solidFill>
-                        <a:srgbClr val="DCE2D6"/>
-                      </a:solidFill>
-                      <a:prstDash val="solid"/>
-                      <a:round/>
-                      <a:headEnd type="none" w="med" len="med"/>
-                      <a:tailEnd type="none" w="med" len="med"/>
-                    </a:lnT>
-                    <a:lnB w="6350" cap="flat" cmpd="sng" algn="ctr">
-                      <a:solidFill>
-                        <a:srgbClr val="DCE2D6"/>
-                      </a:solidFill>
-                      <a:prstDash val="solid"/>
-                      <a:round/>
-                      <a:headEnd type="none" w="med" len="med"/>
-                      <a:tailEnd type="none" w="med" len="med"/>
-                    </a:lnB>
-                  </a:tcPr>
-                </a:tc>
-                <a:tc>
-                  <a:txBody>
-                    <a:bodyPr/>
-                    <a:lstStyle/>
-                    <a:p>
-                      <a:pPr algn="r" indent="0" marL="0">
-                        <a:buNone/>
-                      </a:pPr>
-                      <a:r>
-                        <a:rPr lang="en-US" sz="900" dirty="0">
-                          <a:solidFill>
-                            <a:srgbClr val="2B2F28"/>
-                          </a:solidFill>
-                          <a:latin typeface="Plus Jakarta Sans" pitchFamily="34" charset="0"/>
-                          <a:ea typeface="Plus Jakarta Sans" pitchFamily="34" charset="-122"/>
-                          <a:cs typeface="Plus Jakarta Sans" pitchFamily="34" charset="-120"/>
-                        </a:rPr>
-                        <a:t>1 / 0</a:t>
                       </a:r>
                       <a:endParaRPr lang="en-US" sz="900" dirty="0">
                         <a:latin typeface="Plus Jakarta Sans" charset="0"/>
@@ -9836,7 +9247,7 @@
                 <a:ea typeface="Plus Jakarta Sans" pitchFamily="34" charset="-122"/>
                 <a:cs typeface="Plus Jakarta Sans" pitchFamily="34" charset="-120"/>
               </a:rPr>
-              <a:t>Farmers registered (utm_source)</a:t>
+              <a:t>Farmers registered, by acquisition channel</a:t>
             </a:r>
             <a:endParaRPr lang="en-US" sz="950" dirty="0"/>
           </a:p>
@@ -10957,7 +10368,7 @@
                 <a:ea typeface="Plus Jakarta Sans" pitchFamily="34" charset="-122"/>
                 <a:cs typeface="Plus Jakarta Sans" pitchFamily="34" charset="-120"/>
               </a:rPr>
-              <a:t>Change in farmers (utm_source_name); hover for week before → last week</a:t>
+              <a:t>Change in farmers; hover for week before → last week</a:t>
             </a:r>
             <a:endParaRPr lang="en-US" sz="950" dirty="0"/>
           </a:p>
@@ -11597,7 +11008,27 @@
                 <a:ea typeface="Plus Jakarta Sans" pitchFamily="34" charset="-122"/>
                 <a:cs typeface="Plus Jakarta Sans" pitchFamily="34" charset="-120"/>
               </a:rPr>
-              <a:t>Online_Komunitas_Dow…</a:t>
+              <a:t>Online Komunitas</a:t>
+            </a:r>
+            <a:endParaRPr lang="en-US" sz="900" dirty="0"/>
+          </a:p>
+          <a:p>
+            <a:pPr algn="l" indent="0" marL="0">
+              <a:lnSpc>
+                <a:spcPct val="95000"/>
+              </a:lnSpc>
+              <a:buNone/>
+            </a:pPr>
+            <a:r>
+              <a:rPr lang="en-US" sz="900" dirty="0">
+                <a:solidFill>
+                  <a:srgbClr val="2B2F28"/>
+                </a:solidFill>
+                <a:latin typeface="Plus Jakarta Sans" pitchFamily="34" charset="0"/>
+                <a:ea typeface="Plus Jakarta Sans" pitchFamily="34" charset="-122"/>
+                <a:cs typeface="Plus Jakarta Sans" pitchFamily="34" charset="-120"/>
+              </a:rPr>
+              <a:t>DownloadPSP</a:t>
             </a:r>
             <a:endParaRPr lang="en-US" sz="900" dirty="0"/>
           </a:p>
@@ -11706,7 +11137,7 @@
                 <a:ea typeface="Plus Jakarta Sans" pitchFamily="34" charset="-122"/>
                 <a:cs typeface="Plus Jakarta Sans" pitchFamily="34" charset="-120"/>
               </a:rPr>
-              <a:t>broadcast_500k_farmer</a:t>
+              <a:t>broadcast 500k farmer</a:t>
             </a:r>
             <a:endParaRPr lang="en-US" sz="900" dirty="0"/>
           </a:p>
@@ -12409,7 +11840,7 @@
                 <a:ea typeface="Plus Jakarta Sans" pitchFamily="34" charset="-122"/>
                 <a:cs typeface="Plus Jakarta Sans" pitchFamily="34" charset="-120"/>
               </a:rPr>
-              <a:t>Weeks start on Monday (minggu_register); the week of 12 Oct is left out</a:t>
+              <a:t>Registration weeks start on Monday; the week of 12 Oct is left out</a:t>
             </a:r>
             <a:endParaRPr lang="en-US" sz="950" dirty="0"/>
           </a:p>
@@ -17152,7 +16583,7 @@
                 <a:ea typeface="Plus Jakarta Sans" pitchFamily="34" charset="-122"/>
                 <a:cs typeface="Plus Jakarta Sans" pitchFamily="34" charset="-120"/>
               </a:rPr>
-              <a:t>utm_source</a:t>
+              <a:t>Acquisition channel</a:t>
             </a:r>
             <a:endParaRPr lang="en-US" sz="950" dirty="0"/>
           </a:p>
@@ -20096,7 +19527,7 @@
                 <a:ea typeface="Plus Jakarta Sans" pitchFamily="34" charset="-122"/>
                 <a:cs typeface="Plus Jakarta Sans" pitchFamily="34" charset="-120"/>
               </a:rPr>
-              <a:t>utm_source_name, largest last week first</a:t>
+              <a:t>Largest last week first</a:t>
             </a:r>
             <a:endParaRPr lang="en-US" sz="950" dirty="0"/>
           </a:p>
@@ -21470,7 +20901,7 @@
                           <a:ea typeface="Plus Jakarta Sans" pitchFamily="34" charset="-122"/>
                           <a:cs typeface="Plus Jakarta Sans" pitchFamily="34" charset="-120"/>
                         </a:rPr>
-                        <a:t>(no campaign)</a:t>
+                        <a:t>No campaign</a:t>
                       </a:r>
                       <a:endParaRPr lang="en-US" sz="900" dirty="0">
                         <a:latin typeface="Plus Jakarta Sans" charset="0"/>
@@ -22256,7 +21687,7 @@
                           <a:ea typeface="Plus Jakarta Sans" pitchFamily="34" charset="-122"/>
                           <a:cs typeface="Plus Jakarta Sans" pitchFamily="34" charset="-120"/>
                         </a:rPr>
-                        <a:t>broadcast_500k_farmer</a:t>
+                        <a:t>broadcast 500k farmer</a:t>
                       </a:r>
                       <a:endParaRPr lang="en-US" sz="900" dirty="0">
                         <a:latin typeface="Plus Jakarta Sans" charset="0"/>

</xml_diff>